<commit_message>
Ch723 - RCCM : immatriculation en cours (dossier investisseur, data book, fiche et kit presse) + sw.js
</commit_message>
<xml_diff>
--- a/Dossier_Investisseur_EnerTchad.pptx
+++ b/Dossier_Investisseur_EnerTchad.pptx
@@ -3255,7 +3255,7 @@
                 <a:ea typeface="Calibri" pitchFamily="34" charset="-122"/>
                 <a:cs typeface="Calibri" pitchFamily="34" charset="-120"/>
               </a:rPr>
-              <a:t>RCCM N'DJ/RC/2026-A-0001 · conseil d'administration · 10 actionnaires fondateurs</a:t>
+              <a:t>RCCM en cours d'immatriculation · conseil d'administration · 10 actionnaires fondateurs</a:t>
             </a:r>
             <a:endParaRPr lang="en-US" sz="1000" dirty="0"/>
           </a:p>
@@ -4581,7 +4581,7 @@
                 <a:ea typeface="Calibri" pitchFamily="34" charset="-122"/>
                 <a:cs typeface="Calibri" pitchFamily="34" charset="-120"/>
               </a:rPr>
-              <a:t>RCCM N'DJ/RC/2026-A-0001</a:t>
+              <a:t>RCCM : immatriculation en cours</a:t>
             </a:r>
             <a:endParaRPr lang="en-US" sz="1300" dirty="0"/>
           </a:p>

</xml_diff>